<commit_message>
docs: actualiza la presentación con la arquitectura MVC, las capturas web y los datos del equipo
</commit_message>
<xml_diff>
--- a/docs/Presentacion.pptx
+++ b/docs/Presentacion.pptx
@@ -519,7 +519,7 @@
           <a:lstStyle/>
           <a:p>
             <a:r>
-              <a:t>Presentar el equipo y el sistema elegido: Sistema de biblioteca. Mencionar que el proyecto sigue la ruta problema → requisitos → UML → clases → código → interfaz → archivos → pruebas.</a:t>
+              <a:t>Presentar al equipo y el sistema: una aplicación web de gestión de biblioteca hecha con ASP.NET Core MVC y archivos JSON. Seguimos la ruta problema → requisitos → UML → clases → código → interfaz → archivos → pruebas.</a:t>
             </a:r>
           </a:p>
         </p:txBody>
@@ -589,7 +589,7 @@
           <a:lstStyle/>
           <a:p>
             <a:r>
-              <a:t>Demostrar el menú lateral y la pantalla de inicio: indicadores (libros, usuarios, préstamos activos, atrasados, multas pendientes), accesos rápidos y reglas del servicio.</a:t>
+              <a:t>Demostrar el menú lateral y el inicio: indicadores, próximos vencimientos, accesos rápidos y reglas del servicio.</a:t>
             </a:r>
           </a:p>
         </p:txBody>
@@ -659,7 +659,7 @@
           <a:lstStyle/>
           <a:p>
             <a:r>
-              <a:t>Demo en vivo: registrar un libro con datos inválidos y mostrar el error; luego registrar un préstamo y mostrar que se rechaza a un usuario con libros atrasados.</a:t>
+              <a:t>Demo: registrar un libro con ISBN inválido y mostrar el error; luego registrar un préstamo y mostrar el rechazo a un usuario con libros atrasados.</a:t>
             </a:r>
           </a:p>
         </p:txBody>
@@ -729,7 +729,7 @@
           <a:lstStyle/>
           <a:p>
             <a:r>
-              <a:t>Mostrar búsqueda por título, filtro por categoría y por disponibilidad. En reportes, elegir 'Libros atrasados' y exportar a CSV.</a:t>
+              <a:t>Mostrar búsqueda por título, filtro por categoría y disponibilidad. En reportes, elegir 'Libros atrasados' y exportar a CSV.</a:t>
             </a:r>
           </a:p>
         </p:txBody>
@@ -799,7 +799,7 @@
           <a:lstStyle/>
           <a:p>
             <a:r>
-              <a:t>Explicar que cada cambio serializa la colección completa a un .tmp y reemplaza el archivo original. Solo se guardan datos primarios; las propiedades calculadas se recalculan al cargar. La jerarquía Persona se guarda con un discriminador 'tipo'.</a:t>
+              <a:t>Cada cambio serializa la colección completa a un .tmp y reemplaza el archivo original. Solo se guardan datos primarios. La jerarquía Persona se guarda con el discriminador 'tipo'.</a:t>
             </a:r>
           </a:p>
         </p:txBody>
@@ -869,7 +869,7 @@
           <a:lstStyle/>
           <a:p>
             <a:r>
-              <a:t>Demo: registrar un libro, cerrar la aplicación, abrirla de nuevo y mostrar que sigue ahí. Mencionar la prueba automatizada que reabre el sistema y compara todos los datos, y el manejo de un archivo dañado.</a:t>
+              <a:t>Demo: registrar un libro, detener la aplicación con Ctrl+C, ejecutar dotnet run de nuevo y mostrar que sigue ahí. Mencionar la prueba automatizada que reabre el sistema.</a:t>
             </a:r>
           </a:p>
         </p:txBody>
@@ -939,7 +939,7 @@
           <a:lstStyle/>
           <a:p>
             <a:r>
-              <a:t>Recorrer la cadena de trazabilidad. Los datos de prueba cubren préstamos activos, atrasados y devueltos, una multa pagada y otra pendiente, y un libro sin ejemplares.</a:t>
+              <a:t>Recorrer la cadena de trazabilidad. Los 24 tests de integración levantan la aplicación web completa en memoria y ejercitan controladores, vistas y archivos JSON.</a:t>
             </a:r>
           </a:p>
         </p:txBody>
@@ -1009,7 +1009,7 @@
           <a:lstStyle/>
           <a:p>
             <a:r>
-              <a:t>Contar los problemas reales que aparecieron: por ejemplo, el JSON guardaba propiedades calculadas porque JsonIgnore no se hereda en las sobrescrituras; se detectó al revisar los datos generados y se agregó JsonIgnore más una prueba.</a:t>
+              <a:t>Contar problemas reales: JsonIgnore no se hereda en un override y el JSON guardaba propiedades calculadas; las secciones Razor no se renderizan desde vistas parciales; el dinero salía con coma según la cultura del servidor.</a:t>
             </a:r>
           </a:p>
         </p:txBody>
@@ -1079,7 +1079,7 @@
           <a:lstStyle/>
           <a:p>
             <a:r>
-              <a:t>Mostrar el historial del repositorio: cada commit es un cambio lógico y sigue el formato tipo: descripción en español. El orden refleja la construcción del sistema: base, dominio, persistencia, servicios, pruebas, interfaz y documentación.</a:t>
+              <a:t>Mostrar el historial del repositorio: cada commit es un cambio lógico con el formato tipo: descripción en español. Se ve también el cambio a MVC hecho por capas.</a:t>
             </a:r>
           </a:p>
         </p:txBody>
@@ -1219,7 +1219,7 @@
           <a:lstStyle/>
           <a:p>
             <a:r>
-              <a:t>Explicar la situación actual: cuadernos, fichas y cálculo de multas de memoria. Resaltar que el problema central es la falta de un registro único y consistente que relacione libros, usuarios, préstamos y multas.</a:t>
+              <a:t>Situación actual: cuadernos, fichas y multas calculadas de memoria. El problema central es que no hay un registro único y consistente de libros, usuarios, préstamos y multas.</a:t>
             </a:r>
           </a:p>
         </p:txBody>
@@ -1289,7 +1289,7 @@
           <a:lstStyle/>
           <a:p>
             <a:r>
-              <a:t>Objetivo general: aplicación en C# con POO y UML que gestione catálogo, usuarios, préstamos, devoluciones y multas con archivos JSON. Alcance: los cinco módulos del enunciado. Limitaciones relevantes: un solo puesto de trabajo, sin autenticación, sin reservas.</a:t>
+              <a:t>Objetivo general: aplicación web en C# con POO y UML que gestione catálogo, usuarios, préstamos, devoluciones y multas con archivos JSON. Alcance: los cinco módulos del enunciado.</a:t>
             </a:r>
           </a:p>
         </p:txBody>
@@ -1359,7 +1359,7 @@
           <a:lstStyle/>
           <a:p>
             <a:r>
-              <a:t>Mostrar cómo se organizaron los requisitos por módulo. Mencionar las reglas del negocio clave: límites 3/5 préstamos, plazos 7/14 días, máximo 2 renovaciones, multa Q2.00 por día con tope Q100.00.</a:t>
+              <a:t>Requisitos por módulo. Reglas clave: límites 3/5 préstamos, plazos 7/14 días, máximo 2 renovaciones, multa Q2.00 por día con tope Q100.00.</a:t>
             </a:r>
           </a:p>
         </p:txBody>
@@ -1429,7 +1429,7 @@
           <a:lstStyle/>
           <a:p>
             <a:r>
-              <a:t>Actores: Bibliotecario (principal), Lector (secundario, atendido por el bibliotecario) y los archivos JSON. Señalar la relación include de CU-18 en CU-09 y el extend de CU-14 sobre CU-12 (solo si hay atraso).</a:t>
+              <a:t>Actores: Bibliotecario (principal), Lector (secundario) y los archivos JSON. CU-18 se incluye en CU-09; CU-14 extiende a CU-12 solo si hay atraso.</a:t>
             </a:r>
           </a:p>
         </p:txBody>
@@ -1499,7 +1499,7 @@
           <a:lstStyle/>
           <a:p>
             <a:r>
-              <a:t>Recorrer la jerarquía: EntidadBase aporta el Id; Persona es abstracta con Lector y Bibliotecario; Libro, Prestamo y Multa se relacionan por identificadores. El polimorfismo está en LimitePrestamos y DiasPrestamo.</a:t>
+              <a:t>EntidadBase aporta el Id; Persona es abstracta con Lector y Bibliotecario; Libro, Prestamo y Multa se relacionan por identificadores. El polimorfismo está en LimitePrestamos y DiasPrestamo.</a:t>
             </a:r>
           </a:p>
         </p:txBody>
@@ -1569,7 +1569,7 @@
           <a:lstStyle/>
           <a:p>
             <a:r>
-              <a:t>Seguir el flujo: el formulario llama a PrestamoService, que consulta repositorios, valida reglas y, si todo cumple, crea el préstamo, descuenta el ejemplar y escribe prestamos.json y libros.json. Si falla una regla, se lanza ValidacionException y la interfaz muestra el mensaje.</a:t>
+              <a:t>El formulario envía un POST a PrestamosController, que llama a PrestamoService. Si falla una regla se vuelve a mostrar el formulario con el error; si no, se guardan prestamos.json y libros.json y se redirige con el mensaje de confirmación.</a:t>
             </a:r>
           </a:p>
         </p:txBody>
@@ -1639,7 +1639,7 @@
           <a:lstStyle/>
           <a:p>
             <a:r>
-              <a:t>El diagrama de actividad de préstamo muestra las seis validaciones; el de devolución, el cálculo de la multa. El diagrama de estados resume el ciclo de vida del préstamo: Activo, Atrasado y Devuelto.</a:t>
+              <a:t>La actividad de préstamo muestra las seis validaciones; la de devolución, el cálculo de la multa. El diagrama de estados resume el ciclo Activo → Atrasado → Devuelto.</a:t>
             </a:r>
           </a:p>
         </p:txBody>
@@ -1709,7 +1709,7 @@
           <a:lstStyle/>
           <a:p>
             <a:r>
-              <a:t>La interfaz depende de la lógica, nunca al revés. Por eso la lógica se prueba de forma automática sin abrir la ventana. La persistencia está detrás de la interfaz IRepositorio, así el almacenamiento es intercambiable.</a:t>
+              <a:t>Modelo = Biblioteca.Core, Vista = Views/*.cshtml (Razor + Bootstrap), Controlador = Controllers/*.cs. Los controladores reciben SistemaBiblioteca por inyección de dependencias y llaman a los servicios; el modelo no conoce la web, por eso se prueba sin navegador.</a:t>
             </a:r>
           </a:p>
         </p:txBody>
@@ -4766,7 +4766,7 @@
         </p:nvSpPr>
         <p:spPr>
           <a:xfrm>
-            <a:off x="822960" y="2788920"/>
+            <a:off x="822960" y="2743200"/>
             <a:ext cx="1463040" cy="73152"/>
           </a:xfrm>
           <a:prstGeom prst="rect">
@@ -4809,8 +4809,8 @@
         </p:nvSpPr>
         <p:spPr>
           <a:xfrm>
-            <a:off x="822960" y="1463040"/>
-            <a:ext cx="10058400" cy="1280160"/>
+            <a:off x="822960" y="1280160"/>
+            <a:ext cx="10515600" cy="1280160"/>
           </a:xfrm>
           <a:prstGeom prst="rect">
             <a:avLst/>
@@ -4818,7 +4818,7 @@
           <a:noFill/>
         </p:spPr>
         <p:txBody>
-          <a:bodyPr wrap="square" anchor="t" lIns="45720" rIns="45720">
+          <a:bodyPr wrap="square" lIns="45720" rIns="45720">
             <a:spAutoFit/>
           </a:bodyPr>
           <a:lstStyle/>
@@ -4844,8 +4844,8 @@
         </p:nvSpPr>
         <p:spPr>
           <a:xfrm>
-            <a:off x="822960" y="3017520"/>
-            <a:ext cx="10058400" cy="548640"/>
+            <a:off x="822960" y="2926080"/>
+            <a:ext cx="10515600" cy="548640"/>
           </a:xfrm>
           <a:prstGeom prst="rect">
             <a:avLst/>
@@ -4853,20 +4853,20 @@
           <a:noFill/>
         </p:spPr>
         <p:txBody>
-          <a:bodyPr wrap="square" anchor="t" lIns="45720" rIns="45720">
+          <a:bodyPr wrap="square" lIns="45720" rIns="45720">
             <a:spAutoFit/>
           </a:bodyPr>
           <a:lstStyle/>
           <a:p>
             <a:pPr algn="l"/>
             <a:r>
-              <a:rPr sz="2600" b="0">
+              <a:rPr sz="2400" b="0">
                 <a:solidFill>
                   <a:srgbClr val="C9DBEE"/>
                 </a:solidFill>
                 <a:latin typeface="Calibri"/>
               </a:rPr>
-              <a:t>Proyecto Integrador · Programación II</a:t>
+              <a:t>Aplicación web ASP.NET Core MVC · Proyecto Integrador de Programación II</a:t>
             </a:r>
           </a:p>
         </p:txBody>
@@ -4879,8 +4879,8 @@
         </p:nvSpPr>
         <p:spPr>
           <a:xfrm>
-            <a:off x="822960" y="4114800"/>
-            <a:ext cx="10058400" cy="1280160"/>
+            <a:off x="822960" y="3840480"/>
+            <a:ext cx="10515600" cy="2194560"/>
           </a:xfrm>
           <a:prstGeom prst="rect">
             <a:avLst/>
@@ -4888,7 +4888,7 @@
           <a:noFill/>
         </p:spPr>
         <p:txBody>
-          <a:bodyPr wrap="square" anchor="t" lIns="45720" rIns="45720">
+          <a:bodyPr wrap="square" lIns="45720" rIns="45720">
             <a:spAutoFit/>
           </a:bodyPr>
           <a:lstStyle/>
@@ -4901,7 +4901,7 @@
                 </a:solidFill>
                 <a:latin typeface="Calibri"/>
               </a:rPr>
-              <a:t>[Nombre de la universidad]</a:t>
+              <a:t>Universidad San Pablo de Guatemala</a:t>
             </a:r>
           </a:p>
           <a:p>
@@ -4913,7 +4913,7 @@
                 </a:solidFill>
                 <a:latin typeface="Calibri"/>
               </a:rPr>
-              <a:t>Integrantes: [Nombres y carnés]</a:t>
+              <a:t>Angela María Cruz Cifuentes (2600094)</a:t>
             </a:r>
           </a:p>
           <a:p>
@@ -4925,7 +4925,31 @@
                 </a:solidFill>
                 <a:latin typeface="Calibri"/>
               </a:rPr>
-              <a:t>Catedrático: [Nombre del catedrático]</a:t>
+              <a:t>Carlos Fernando Villatoro López (2600447)</a:t>
+            </a:r>
+          </a:p>
+          <a:p>
+            <a:pPr algn="l"/>
+            <a:r>
+              <a:rPr sz="1800" b="0">
+                <a:solidFill>
+                  <a:srgbClr val="C9DBEE"/>
+                </a:solidFill>
+                <a:latin typeface="Calibri"/>
+              </a:rPr>
+              <a:t>Angel Kaled Rodriguez Soc (2600100)</a:t>
+            </a:r>
+          </a:p>
+          <a:p>
+            <a:pPr algn="l"/>
+            <a:r>
+              <a:rPr sz="1800" b="0">
+                <a:solidFill>
+                  <a:srgbClr val="C9DBEE"/>
+                </a:solidFill>
+                <a:latin typeface="Calibri"/>
+              </a:rPr>
+              <a:t>Catedrático: Erik Arnulfo Santizo Bardales</a:t>
             </a:r>
           </a:p>
           <a:p>
@@ -5020,7 +5044,7 @@
           <a:noFill/>
         </p:spPr>
         <p:txBody>
-          <a:bodyPr wrap="square" anchor="t" lIns="45720" rIns="45720">
+          <a:bodyPr wrap="square" lIns="45720" rIns="45720">
             <a:spAutoFit/>
           </a:bodyPr>
           <a:lstStyle/>
@@ -5055,7 +5079,7 @@
           <a:noFill/>
         </p:spPr>
         <p:txBody>
-          <a:bodyPr wrap="square" anchor="t" lIns="45720" rIns="45720">
+          <a:bodyPr wrap="square" lIns="45720" rIns="45720">
             <a:spAutoFit/>
           </a:bodyPr>
           <a:lstStyle/>
@@ -5068,7 +5092,7 @@
                 </a:solidFill>
                 <a:latin typeface="Calibri"/>
               </a:rPr>
-              <a:t>Menú principal y navegación por módulos</a:t>
+              <a:t>Menú lateral, botones de navegación y accesos rápidos</a:t>
             </a:r>
           </a:p>
         </p:txBody>
@@ -5090,7 +5114,7 @@
           <a:noFill/>
         </p:spPr>
         <p:txBody>
-          <a:bodyPr wrap="square" anchor="t" lIns="45720" rIns="45720">
+          <a:bodyPr wrap="square" lIns="45720" rIns="45720">
             <a:spAutoFit/>
           </a:bodyPr>
           <a:lstStyle/>
@@ -5103,7 +5127,7 @@
                 </a:solidFill>
                 <a:latin typeface="Calibri"/>
               </a:rPr>
-              <a:t>Sistema de biblioteca · Programación II</a:t>
+              <a:t>Sistema de biblioteca · Programación II · Universidad San Pablo de Guatemala</a:t>
             </a:r>
           </a:p>
         </p:txBody>
@@ -5125,7 +5149,7 @@
           <a:noFill/>
         </p:spPr>
         <p:txBody>
-          <a:bodyPr wrap="square" anchor="t" lIns="45720" rIns="45720">
+          <a:bodyPr wrap="square" lIns="45720" rIns="45720">
             <a:spAutoFit/>
           </a:bodyPr>
           <a:lstStyle/>
@@ -5159,8 +5183,8 @@
         </p:blipFill>
         <p:spPr>
           <a:xfrm>
-            <a:off x="548640" y="1601628"/>
-            <a:ext cx="7498079" cy="4569142"/>
+            <a:off x="548640" y="1543050"/>
+            <a:ext cx="7498079" cy="4686300"/>
           </a:xfrm>
           <a:prstGeom prst="rect">
             <a:avLst/>
@@ -5236,7 +5260,7 @@
           <a:noFill/>
         </p:spPr>
         <p:txBody>
-          <a:bodyPr wrap="square" anchor="t" lIns="45720" rIns="45720">
+          <a:bodyPr wrap="square" lIns="45720" rIns="45720">
             <a:spAutoFit/>
           </a:bodyPr>
           <a:lstStyle/>
@@ -5352,7 +5376,7 @@
                 </a:solidFill>
                 <a:latin typeface="Calibri"/>
               </a:rPr>
-              <a:t>• Mensajes de error y validación</a:t>
+              <a:t>• Mensajes de éxito y de error</a:t>
             </a:r>
           </a:p>
         </p:txBody>
@@ -5435,7 +5459,7 @@
           <a:noFill/>
         </p:spPr>
         <p:txBody>
-          <a:bodyPr wrap="square" anchor="t" lIns="45720" rIns="45720">
+          <a:bodyPr wrap="square" lIns="45720" rIns="45720">
             <a:spAutoFit/>
           </a:bodyPr>
           <a:lstStyle/>
@@ -5470,7 +5494,7 @@
           <a:noFill/>
         </p:spPr>
         <p:txBody>
-          <a:bodyPr wrap="square" anchor="t" lIns="45720" rIns="45720">
+          <a:bodyPr wrap="square" lIns="45720" rIns="45720">
             <a:spAutoFit/>
           </a:bodyPr>
           <a:lstStyle/>
@@ -5483,7 +5507,7 @@
                 </a:solidFill>
                 <a:latin typeface="Calibri"/>
               </a:rPr>
-              <a:t>Formularios con validación de datos</a:t>
+              <a:t>Formularios con validación de datos en el servidor</a:t>
             </a:r>
           </a:p>
         </p:txBody>
@@ -5505,7 +5529,7 @@
           <a:noFill/>
         </p:spPr>
         <p:txBody>
-          <a:bodyPr wrap="square" anchor="t" lIns="45720" rIns="45720">
+          <a:bodyPr wrap="square" lIns="45720" rIns="45720">
             <a:spAutoFit/>
           </a:bodyPr>
           <a:lstStyle/>
@@ -5518,7 +5542,7 @@
                 </a:solidFill>
                 <a:latin typeface="Calibri"/>
               </a:rPr>
-              <a:t>Sistema de biblioteca · Programación II</a:t>
+              <a:t>Sistema de biblioteca · Programación II · Universidad San Pablo de Guatemala</a:t>
             </a:r>
           </a:p>
         </p:txBody>
@@ -5540,7 +5564,7 @@
           <a:noFill/>
         </p:spPr>
         <p:txBody>
-          <a:bodyPr wrap="square" anchor="t" lIns="45720" rIns="45720">
+          <a:bodyPr wrap="square" lIns="45720" rIns="45720">
             <a:spAutoFit/>
           </a:bodyPr>
           <a:lstStyle/>
@@ -5574,8 +5598,8 @@
         </p:blipFill>
         <p:spPr>
           <a:xfrm>
-            <a:off x="548640" y="1770017"/>
-            <a:ext cx="3657600" cy="2952205"/>
+            <a:off x="457200" y="2074544"/>
+            <a:ext cx="3749039" cy="2343150"/>
           </a:xfrm>
           <a:prstGeom prst="rect">
             <a:avLst/>
@@ -5603,8 +5627,8 @@
         </p:blipFill>
         <p:spPr>
           <a:xfrm>
-            <a:off x="4343400" y="1665514"/>
-            <a:ext cx="3657600" cy="3161211"/>
+            <a:off x="4251960" y="2074544"/>
+            <a:ext cx="3749039" cy="2343150"/>
           </a:xfrm>
           <a:prstGeom prst="rect">
             <a:avLst/>
@@ -5632,8 +5656,8 @@
         </p:blipFill>
         <p:spPr>
           <a:xfrm>
-            <a:off x="8138160" y="2093175"/>
-            <a:ext cx="3520440" cy="2305888"/>
+            <a:off x="8046720" y="2074544"/>
+            <a:ext cx="3749039" cy="2343150"/>
           </a:xfrm>
           <a:prstGeom prst="rect">
             <a:avLst/>
@@ -5653,7 +5677,7 @@
         </p:nvSpPr>
         <p:spPr>
           <a:xfrm>
-            <a:off x="548640" y="5120640"/>
+            <a:off x="548640" y="5212080"/>
             <a:ext cx="11064240" cy="365760"/>
           </a:xfrm>
           <a:prstGeom prst="rect">
@@ -5662,7 +5686,7 @@
           <a:noFill/>
         </p:spPr>
         <p:txBody>
-          <a:bodyPr wrap="square" anchor="t" lIns="45720" rIns="45720">
+          <a:bodyPr wrap="square" lIns="45720" rIns="45720">
             <a:spAutoFit/>
           </a:bodyPr>
           <a:lstStyle/>
@@ -5675,7 +5699,7 @@
                 </a:solidFill>
                 <a:latin typeface="Calibri"/>
               </a:rPr>
-              <a:t>Los errores se muestran en el formulario; las reglas de negocio se validan en la capa de lógica.</a:t>
+              <a:t>El error aparece dentro del formulario; las reglas de negocio se validan en la capa de lógica, no en la vista.</a:t>
             </a:r>
           </a:p>
         </p:txBody>
@@ -5688,8 +5712,8 @@
         </p:nvSpPr>
         <p:spPr>
           <a:xfrm>
-            <a:off x="548640" y="5532120"/>
-            <a:ext cx="11064240" cy="822960"/>
+            <a:off x="548640" y="5623560"/>
+            <a:ext cx="11064240" cy="731520"/>
           </a:xfrm>
           <a:prstGeom prst="rect">
             <a:avLst/>
@@ -5714,7 +5738,7 @@
                 </a:solidFill>
                 <a:latin typeface="Calibri"/>
               </a:rPr>
-              <a:t>• Formato de ISBN, DPI, correo y teléfono · unicidad · límites y bloqueos del préstamo</a:t>
+              <a:t>• Formato de ISBN, DPI, correo y teléfono · unicidad · límites y bloqueos del préstamo · token antiforgery</a:t>
             </a:r>
           </a:p>
         </p:txBody>
@@ -5797,7 +5821,7 @@
           <a:noFill/>
         </p:spPr>
         <p:txBody>
-          <a:bodyPr wrap="square" anchor="t" lIns="45720" rIns="45720">
+          <a:bodyPr wrap="square" lIns="45720" rIns="45720">
             <a:spAutoFit/>
           </a:bodyPr>
           <a:lstStyle/>
@@ -5832,7 +5856,7 @@
           <a:noFill/>
         </p:spPr>
         <p:txBody>
-          <a:bodyPr wrap="square" anchor="t" lIns="45720" rIns="45720">
+          <a:bodyPr wrap="square" lIns="45720" rIns="45720">
             <a:spAutoFit/>
           </a:bodyPr>
           <a:lstStyle/>
@@ -5867,7 +5891,7 @@
           <a:noFill/>
         </p:spPr>
         <p:txBody>
-          <a:bodyPr wrap="square" anchor="t" lIns="45720" rIns="45720">
+          <a:bodyPr wrap="square" lIns="45720" rIns="45720">
             <a:spAutoFit/>
           </a:bodyPr>
           <a:lstStyle/>
@@ -5880,7 +5904,7 @@
                 </a:solidFill>
                 <a:latin typeface="Calibri"/>
               </a:rPr>
-              <a:t>Sistema de biblioteca · Programación II</a:t>
+              <a:t>Sistema de biblioteca · Programación II · Universidad San Pablo de Guatemala</a:t>
             </a:r>
           </a:p>
         </p:txBody>
@@ -5902,7 +5926,7 @@
           <a:noFill/>
         </p:spPr>
         <p:txBody>
-          <a:bodyPr wrap="square" anchor="t" lIns="45720" rIns="45720">
+          <a:bodyPr wrap="square" lIns="45720" rIns="45720">
             <a:spAutoFit/>
           </a:bodyPr>
           <a:lstStyle/>
@@ -5936,8 +5960,8 @@
         </p:blipFill>
         <p:spPr>
           <a:xfrm>
-            <a:off x="548640" y="2168842"/>
-            <a:ext cx="5486400" cy="3343275"/>
+            <a:off x="548640" y="2125980"/>
+            <a:ext cx="5486400" cy="3429000"/>
           </a:xfrm>
           <a:prstGeom prst="rect">
             <a:avLst/>
@@ -5965,8 +5989,8 @@
         </p:blipFill>
         <p:spPr>
           <a:xfrm>
-            <a:off x="6172200" y="2168842"/>
-            <a:ext cx="5486400" cy="3343275"/>
+            <a:off x="6172200" y="2125980"/>
+            <a:ext cx="5486400" cy="3429000"/>
           </a:xfrm>
           <a:prstGeom prst="rect">
             <a:avLst/>
@@ -6056,7 +6080,7 @@
           <a:noFill/>
         </p:spPr>
         <p:txBody>
-          <a:bodyPr wrap="square" anchor="t" lIns="45720" rIns="45720">
+          <a:bodyPr wrap="square" lIns="45720" rIns="45720">
             <a:spAutoFit/>
           </a:bodyPr>
           <a:lstStyle/>
@@ -6091,7 +6115,7 @@
           <a:noFill/>
         </p:spPr>
         <p:txBody>
-          <a:bodyPr wrap="square" anchor="t" lIns="45720" rIns="45720">
+          <a:bodyPr wrap="square" lIns="45720" rIns="45720">
             <a:spAutoFit/>
           </a:bodyPr>
           <a:lstStyle/>
@@ -6104,7 +6128,7 @@
                 </a:solidFill>
                 <a:latin typeface="Calibri"/>
               </a:rPr>
-              <a:t>Cuatro archivos, escritura atómica</a:t>
+              <a:t>Cuatro archivos en la carpeta Data, escritura atómica</a:t>
             </a:r>
           </a:p>
         </p:txBody>
@@ -6126,7 +6150,7 @@
           <a:noFill/>
         </p:spPr>
         <p:txBody>
-          <a:bodyPr wrap="square" anchor="t" lIns="45720" rIns="45720">
+          <a:bodyPr wrap="square" lIns="45720" rIns="45720">
             <a:spAutoFit/>
           </a:bodyPr>
           <a:lstStyle/>
@@ -6139,7 +6163,7 @@
                 </a:solidFill>
                 <a:latin typeface="Calibri"/>
               </a:rPr>
-              <a:t>Sistema de biblioteca · Programación II</a:t>
+              <a:t>Sistema de biblioteca · Programación II · Universidad San Pablo de Guatemala</a:t>
             </a:r>
           </a:p>
         </p:txBody>
@@ -6161,7 +6185,7 @@
           <a:noFill/>
         </p:spPr>
         <p:txBody>
-          <a:bodyPr wrap="square" anchor="t" lIns="45720" rIns="45720">
+          <a:bodyPr wrap="square" lIns="45720" rIns="45720">
             <a:spAutoFit/>
           </a:bodyPr>
           <a:lstStyle/>
@@ -6241,7 +6265,7 @@
           <a:noFill/>
         </p:spPr>
         <p:txBody>
-          <a:bodyPr wrap="square" anchor="t" lIns="45720" rIns="45720">
+          <a:bodyPr wrap="square" lIns="45720" rIns="45720">
             <a:spAutoFit/>
           </a:bodyPr>
           <a:lstStyle/>
@@ -6443,7 +6467,7 @@
           <a:noFill/>
         </p:spPr>
         <p:txBody>
-          <a:bodyPr wrap="square" anchor="t" lIns="45720" rIns="45720">
+          <a:bodyPr wrap="square" lIns="45720" rIns="45720">
             <a:spAutoFit/>
           </a:bodyPr>
           <a:lstStyle/>
@@ -6687,7 +6711,7 @@
           <a:noFill/>
         </p:spPr>
         <p:txBody>
-          <a:bodyPr wrap="square" anchor="t" lIns="45720" rIns="45720">
+          <a:bodyPr wrap="square" lIns="45720" rIns="45720">
             <a:spAutoFit/>
           </a:bodyPr>
           <a:lstStyle/>
@@ -6722,7 +6746,7 @@
           <a:noFill/>
         </p:spPr>
         <p:txBody>
-          <a:bodyPr wrap="square" anchor="t" lIns="45720" rIns="45720">
+          <a:bodyPr wrap="square" lIns="45720" rIns="45720">
             <a:spAutoFit/>
           </a:bodyPr>
           <a:lstStyle/>
@@ -6735,7 +6759,7 @@
                 </a:solidFill>
                 <a:latin typeface="Calibri"/>
               </a:rPr>
-              <a:t>Los datos permanecen al cerrar y volver a abrir</a:t>
+              <a:t>Los datos permanecen al detener y volver a iniciar la aplicación</a:t>
             </a:r>
           </a:p>
         </p:txBody>
@@ -6757,7 +6781,7 @@
           <a:noFill/>
         </p:spPr>
         <p:txBody>
-          <a:bodyPr wrap="square" anchor="t" lIns="45720" rIns="45720">
+          <a:bodyPr wrap="square" lIns="45720" rIns="45720">
             <a:spAutoFit/>
           </a:bodyPr>
           <a:lstStyle/>
@@ -6770,7 +6794,7 @@
                 </a:solidFill>
                 <a:latin typeface="Calibri"/>
               </a:rPr>
-              <a:t>Sistema de biblioteca · Programación II</a:t>
+              <a:t>Sistema de biblioteca · Programación II · Universidad San Pablo de Guatemala</a:t>
             </a:r>
           </a:p>
         </p:txBody>
@@ -6792,7 +6816,7 @@
           <a:noFill/>
         </p:spPr>
         <p:txBody>
-          <a:bodyPr wrap="square" anchor="t" lIns="45720" rIns="45720">
+          <a:bodyPr wrap="square" lIns="45720" rIns="45720">
             <a:spAutoFit/>
           </a:bodyPr>
           <a:lstStyle/>
@@ -6870,7 +6894,7 @@
           <a:noFill/>
         </p:spPr>
         <p:txBody>
-          <a:bodyPr wrap="square" anchor="t" lIns="45720" rIns="45720">
+          <a:bodyPr wrap="square" lIns="45720" rIns="45720">
             <a:spAutoFit/>
           </a:bodyPr>
           <a:lstStyle/>
@@ -6905,7 +6929,7 @@
           <a:noFill/>
         </p:spPr>
         <p:txBody>
-          <a:bodyPr wrap="square" anchor="t" lIns="45720" rIns="45720">
+          <a:bodyPr wrap="square" lIns="45720" rIns="45720">
             <a:spAutoFit/>
           </a:bodyPr>
           <a:lstStyle/>
@@ -6918,7 +6942,7 @@
                 </a:solidFill>
                 <a:latin typeface="Calibri"/>
               </a:rPr>
-              <a:t>Se abre la app</a:t>
+              <a:t>Se inicia la app</a:t>
             </a:r>
           </a:p>
         </p:txBody>
@@ -6940,7 +6964,7 @@
           <a:noFill/>
         </p:spPr>
         <p:txBody>
-          <a:bodyPr wrap="square" anchor="t" lIns="45720" rIns="45720">
+          <a:bodyPr wrap="square" lIns="45720" rIns="45720">
             <a:spAutoFit/>
           </a:bodyPr>
           <a:lstStyle/>
@@ -7018,7 +7042,7 @@
           <a:noFill/>
         </p:spPr>
         <p:txBody>
-          <a:bodyPr wrap="square" anchor="t" lIns="45720" rIns="45720">
+          <a:bodyPr wrap="square" lIns="45720" rIns="45720">
             <a:spAutoFit/>
           </a:bodyPr>
           <a:lstStyle/>
@@ -7053,7 +7077,7 @@
           <a:noFill/>
         </p:spPr>
         <p:txBody>
-          <a:bodyPr wrap="square" anchor="t" lIns="45720" rIns="45720">
+          <a:bodyPr wrap="square" lIns="45720" rIns="45720">
             <a:spAutoFit/>
           </a:bodyPr>
           <a:lstStyle/>
@@ -7088,7 +7112,7 @@
           <a:noFill/>
         </p:spPr>
         <p:txBody>
-          <a:bodyPr wrap="square" anchor="t" lIns="45720" rIns="45720">
+          <a:bodyPr wrap="square" lIns="45720" rIns="45720">
             <a:spAutoFit/>
           </a:bodyPr>
           <a:lstStyle/>
@@ -7166,7 +7190,7 @@
           <a:noFill/>
         </p:spPr>
         <p:txBody>
-          <a:bodyPr wrap="square" anchor="t" lIns="45720" rIns="45720">
+          <a:bodyPr wrap="square" lIns="45720" rIns="45720">
             <a:spAutoFit/>
           </a:bodyPr>
           <a:lstStyle/>
@@ -7201,7 +7225,7 @@
           <a:noFill/>
         </p:spPr>
         <p:txBody>
-          <a:bodyPr wrap="square" anchor="t" lIns="45720" rIns="45720">
+          <a:bodyPr wrap="square" lIns="45720" rIns="45720">
             <a:spAutoFit/>
           </a:bodyPr>
           <a:lstStyle/>
@@ -7214,7 +7238,7 @@
                 </a:solidFill>
                 <a:latin typeface="Calibri"/>
               </a:rPr>
-              <a:t>Se cierra la app</a:t>
+              <a:t>Se detiene la app</a:t>
             </a:r>
           </a:p>
         </p:txBody>
@@ -7236,7 +7260,7 @@
           <a:noFill/>
         </p:spPr>
         <p:txBody>
-          <a:bodyPr wrap="square" anchor="t" lIns="45720" rIns="45720">
+          <a:bodyPr wrap="square" lIns="45720" rIns="45720">
             <a:spAutoFit/>
           </a:bodyPr>
           <a:lstStyle/>
@@ -7249,7 +7273,7 @@
                 </a:solidFill>
                 <a:latin typeface="Calibri"/>
               </a:rPr>
-              <a:t>No hay paso de guardado manual: todo ya está en disco</a:t>
+              <a:t>No hay guardado manual: todo ya está en Data/</a:t>
             </a:r>
           </a:p>
         </p:txBody>
@@ -7314,7 +7338,7 @@
           <a:noFill/>
         </p:spPr>
         <p:txBody>
-          <a:bodyPr wrap="square" anchor="t" lIns="45720" rIns="45720">
+          <a:bodyPr wrap="square" lIns="45720" rIns="45720">
             <a:spAutoFit/>
           </a:bodyPr>
           <a:lstStyle/>
@@ -7349,7 +7373,7 @@
           <a:noFill/>
         </p:spPr>
         <p:txBody>
-          <a:bodyPr wrap="square" anchor="t" lIns="45720" rIns="45720">
+          <a:bodyPr wrap="square" lIns="45720" rIns="45720">
             <a:spAutoFit/>
           </a:bodyPr>
           <a:lstStyle/>
@@ -7362,7 +7386,7 @@
                 </a:solidFill>
                 <a:latin typeface="Calibri"/>
               </a:rPr>
-              <a:t>Se vuelve a abrir</a:t>
+              <a:t>Se vuelve a iniciar</a:t>
             </a:r>
           </a:p>
         </p:txBody>
@@ -7384,7 +7408,7 @@
           <a:noFill/>
         </p:spPr>
         <p:txBody>
-          <a:bodyPr wrap="square" anchor="t" lIns="45720" rIns="45720">
+          <a:bodyPr wrap="square" lIns="45720" rIns="45720">
             <a:spAutoFit/>
           </a:bodyPr>
           <a:lstStyle/>
@@ -7466,7 +7490,7 @@
           <a:noFill/>
         </p:spPr>
         <p:txBody>
-          <a:bodyPr wrap="square" anchor="t" lIns="45720" rIns="45720">
+          <a:bodyPr wrap="square" lIns="45720" rIns="45720">
             <a:spAutoFit/>
           </a:bodyPr>
           <a:lstStyle/>
@@ -7518,7 +7542,7 @@
                 </a:solidFill>
                 <a:latin typeface="Calibri"/>
               </a:rPr>
-              <a:t>• Dañado: error claro y la app no abre con datos incompletos</a:t>
+              <a:t>• Dañado: la app no inicia y muestra el archivo con el problema</a:t>
             </a:r>
           </a:p>
           <a:p>
@@ -7603,7 +7627,7 @@
           <a:noFill/>
         </p:spPr>
         <p:txBody>
-          <a:bodyPr wrap="square" anchor="t" lIns="45720" rIns="45720">
+          <a:bodyPr wrap="square" lIns="45720" rIns="45720">
             <a:spAutoFit/>
           </a:bodyPr>
           <a:lstStyle/>
@@ -7754,7 +7778,7 @@
           <a:noFill/>
         </p:spPr>
         <p:txBody>
-          <a:bodyPr wrap="square" anchor="t" lIns="45720" rIns="45720">
+          <a:bodyPr wrap="square" lIns="45720" rIns="45720">
             <a:spAutoFit/>
           </a:bodyPr>
           <a:lstStyle/>
@@ -7789,7 +7813,7 @@
           <a:noFill/>
         </p:spPr>
         <p:txBody>
-          <a:bodyPr wrap="square" anchor="t" lIns="45720" rIns="45720">
+          <a:bodyPr wrap="square" lIns="45720" rIns="45720">
             <a:spAutoFit/>
           </a:bodyPr>
           <a:lstStyle/>
@@ -7802,7 +7826,7 @@
                 </a:solidFill>
                 <a:latin typeface="Calibri"/>
               </a:rPr>
-              <a:t>70 pruebas automatizadas y datos de prueba completos</a:t>
+              <a:t>94 pruebas automatizadas y datos de prueba completos</a:t>
             </a:r>
           </a:p>
         </p:txBody>
@@ -7824,7 +7848,7 @@
           <a:noFill/>
         </p:spPr>
         <p:txBody>
-          <a:bodyPr wrap="square" anchor="t" lIns="45720" rIns="45720">
+          <a:bodyPr wrap="square" lIns="45720" rIns="45720">
             <a:spAutoFit/>
           </a:bodyPr>
           <a:lstStyle/>
@@ -7837,7 +7861,7 @@
                 </a:solidFill>
                 <a:latin typeface="Calibri"/>
               </a:rPr>
-              <a:t>Sistema de biblioteca · Programación II</a:t>
+              <a:t>Sistema de biblioteca · Programación II · Universidad San Pablo de Guatemala</a:t>
             </a:r>
           </a:p>
         </p:txBody>
@@ -7859,7 +7883,7 @@
           <a:noFill/>
         </p:spPr>
         <p:txBody>
-          <a:bodyPr wrap="square" anchor="t" lIns="45720" rIns="45720">
+          <a:bodyPr wrap="square" lIns="45720" rIns="45720">
             <a:spAutoFit/>
           </a:bodyPr>
           <a:lstStyle/>
@@ -7913,7 +7937,7 @@
           </a:fontRef>
         </p:style>
         <p:txBody>
-          <a:bodyPr rtlCol="0" anchor="ctr" wrap="square"/>
+          <a:bodyPr rtlCol="0" anchor="ctr"/>
           <a:lstStyle/>
           <a:p>
             <a:pPr algn="ctr"/>
@@ -7965,7 +7989,7 @@
           </a:fontRef>
         </p:style>
         <p:txBody>
-          <a:bodyPr rtlCol="0" anchor="ctr" wrap="square"/>
+          <a:bodyPr rtlCol="0" anchor="ctr"/>
           <a:lstStyle/>
           <a:p>
             <a:pPr algn="ctr"/>
@@ -8017,7 +8041,7 @@
           </a:fontRef>
         </p:style>
         <p:txBody>
-          <a:bodyPr rtlCol="0" anchor="ctr" wrap="square"/>
+          <a:bodyPr rtlCol="0" anchor="ctr"/>
           <a:lstStyle/>
           <a:p>
             <a:pPr algn="ctr"/>
@@ -8069,7 +8093,7 @@
           </a:fontRef>
         </p:style>
         <p:txBody>
-          <a:bodyPr rtlCol="0" anchor="ctr" wrap="square"/>
+          <a:bodyPr rtlCol="0" anchor="ctr"/>
           <a:lstStyle/>
           <a:p>
             <a:pPr algn="ctr"/>
@@ -8121,7 +8145,7 @@
           </a:fontRef>
         </p:style>
         <p:txBody>
-          <a:bodyPr rtlCol="0" anchor="ctr" wrap="square"/>
+          <a:bodyPr rtlCol="0" anchor="ctr"/>
           <a:lstStyle/>
           <a:p>
             <a:pPr algn="ctr"/>
@@ -8173,7 +8197,7 @@
           </a:fontRef>
         </p:style>
         <p:txBody>
-          <a:bodyPr rtlCol="0" anchor="ctr" wrap="square"/>
+          <a:bodyPr rtlCol="0" anchor="ctr"/>
           <a:lstStyle/>
           <a:p>
             <a:pPr algn="ctr"/>
@@ -8225,7 +8249,7 @@
           </a:fontRef>
         </p:style>
         <p:txBody>
-          <a:bodyPr rtlCol="0" anchor="ctr" wrap="square"/>
+          <a:bodyPr rtlCol="0" anchor="ctr"/>
           <a:lstStyle/>
           <a:p>
             <a:pPr algn="ctr"/>
@@ -8277,7 +8301,7 @@
           </a:fontRef>
         </p:style>
         <p:txBody>
-          <a:bodyPr rtlCol="0" anchor="ctr" wrap="square"/>
+          <a:bodyPr rtlCol="0" anchor="ctr"/>
           <a:lstStyle/>
           <a:p>
             <a:pPr algn="ctr"/>
@@ -8357,7 +8381,7 @@
           <a:noFill/>
         </p:spPr>
         <p:txBody>
-          <a:bodyPr wrap="square" anchor="t" lIns="45720" rIns="45720">
+          <a:bodyPr wrap="square" lIns="45720" rIns="45720">
             <a:spAutoFit/>
           </a:bodyPr>
           <a:lstStyle/>
@@ -8409,7 +8433,7 @@
                 </a:solidFill>
                 <a:latin typeface="Calibri"/>
               </a:rPr>
-              <a:t>• Dominio: ISBN, préstamos, multas, polimorfismo</a:t>
+              <a:t>• 70 de dominio, servicios y persistencia</a:t>
             </a:r>
           </a:p>
           <a:p>
@@ -8425,7 +8449,7 @@
                 </a:solidFill>
                 <a:latin typeface="Calibri"/>
               </a:rPr>
-              <a:t>• Servicios: reglas, bloqueos, flujo completo</a:t>
+              <a:t>• 24 de integración de la aplicación web MVC</a:t>
             </a:r>
           </a:p>
           <a:p>
@@ -8441,7 +8465,7 @@
                 </a:solidFill>
                 <a:latin typeface="Calibri"/>
               </a:rPr>
-              <a:t>• Persistencia: reabrir, archivo dañado</a:t>
+              <a:t>• Reglas, bloqueos, flujo completo, archivo dañado</a:t>
             </a:r>
           </a:p>
           <a:p>
@@ -8457,7 +8481,7 @@
                 </a:solidFill>
                 <a:latin typeface="Calibri"/>
               </a:rPr>
-              <a:t>• Datos de prueba consistentes y con todos los estados</a:t>
+              <a:t>• Envíos sin token antiforgery rechazados</a:t>
             </a:r>
           </a:p>
         </p:txBody>
@@ -8526,7 +8550,7 @@
           <a:noFill/>
         </p:spPr>
         <p:txBody>
-          <a:bodyPr wrap="square" anchor="t" lIns="45720" rIns="45720">
+          <a:bodyPr wrap="square" lIns="45720" rIns="45720">
             <a:spAutoFit/>
           </a:bodyPr>
           <a:lstStyle/>
@@ -8539,7 +8563,7 @@
                 </a:solidFill>
                 <a:latin typeface="Calibri"/>
               </a:rPr>
-              <a:t>Datos de prueba</a:t>
+              <a:t>Datos de prueba (Data/)</a:t>
             </a:r>
           </a:p>
         </p:txBody>
@@ -8709,7 +8733,7 @@
           <a:noFill/>
         </p:spPr>
         <p:txBody>
-          <a:bodyPr wrap="square" anchor="t" lIns="45720" rIns="45720">
+          <a:bodyPr wrap="square" lIns="45720" rIns="45720">
             <a:spAutoFit/>
           </a:bodyPr>
           <a:lstStyle/>
@@ -8744,7 +8768,7 @@
           <a:noFill/>
         </p:spPr>
         <p:txBody>
-          <a:bodyPr wrap="square" anchor="t" lIns="45720" rIns="45720">
+          <a:bodyPr wrap="square" lIns="45720" rIns="45720">
             <a:spAutoFit/>
           </a:bodyPr>
           <a:lstStyle/>
@@ -8757,7 +8781,7 @@
                 </a:solidFill>
                 <a:latin typeface="Calibri"/>
               </a:rPr>
-              <a:t>Sistema de biblioteca · Programación II</a:t>
+              <a:t>Sistema de biblioteca · Programación II · Universidad San Pablo de Guatemala</a:t>
             </a:r>
           </a:p>
         </p:txBody>
@@ -8779,7 +8803,7 @@
           <a:noFill/>
         </p:spPr>
         <p:txBody>
-          <a:bodyPr wrap="square" anchor="t" lIns="45720" rIns="45720">
+          <a:bodyPr wrap="square" lIns="45720" rIns="45720">
             <a:spAutoFit/>
           </a:bodyPr>
           <a:lstStyle/>
@@ -8900,7 +8924,7 @@
                           </a:solidFill>
                           <a:latin typeface="Calibri"/>
                         </a:rPr>
-                        <a:t>Atributo JsonIgnore en cada override y prueba que verifica que no se persisten</a:t>
+                        <a:t>JsonIgnore en cada override y una prueba que verifica que no se guardan</a:t>
                       </a:r>
                     </a:p>
                   </a:txBody>
@@ -8946,7 +8970,7 @@
                           </a:solidFill>
                           <a:latin typeface="Calibri"/>
                         </a:rPr>
-                        <a:t>JsonPolymorphic y JsonDerivedType, JsonInclude y constructor privado para el deserializador</a:t>
+                        <a:t>JsonPolymorphic, JsonDerivedType, JsonInclude y constructor privado para el deserializador</a:t>
                       </a:r>
                     </a:p>
                   </a:txBody>
@@ -9016,7 +9040,7 @@
                           </a:solidFill>
                           <a:latin typeface="Calibri"/>
                         </a:rPr>
-                        <a:t>Evitar archivos corruptos si falla una escritura</a:t>
+                        <a:t>El script de un formulario no se ejecutaba: las secciones Razor no funcionan dentro de vistas parciales</a:t>
                       </a:r>
                     </a:p>
                   </a:txBody>
@@ -9038,7 +9062,7 @@
                           </a:solidFill>
                           <a:latin typeface="Calibri"/>
                         </a:rPr>
-                        <a:t>Escritura en archivo temporal y reemplazo del original</a:t>
+                        <a:t>Se movió la sección a la vista Crear; lo detectaron las pruebas en Chrome</a:t>
                       </a:r>
                     </a:p>
                   </a:txBody>
@@ -9062,7 +9086,7 @@
                           </a:solidFill>
                           <a:latin typeface="Calibri"/>
                         </a:rPr>
-                        <a:t>Probar vencimientos y multas que dependen de la fecha</a:t>
+                        <a:t>Montos con coma o con punto según la cultura del servidor (Q14,00 y Q14.00)</a:t>
                       </a:r>
                     </a:p>
                   </a:txBody>
@@ -9084,7 +9108,7 @@
                           </a:solidFill>
                           <a:latin typeface="Calibri"/>
                         </a:rPr>
-                        <a:t>Interfaz IReloj inyectable</a:t>
+                        <a:t>Cultura es-GT fija en Program.cs</a:t>
                       </a:r>
                     </a:p>
                   </a:txBody>
@@ -9108,7 +9132,7 @@
                           </a:solidFill>
                           <a:latin typeface="Calibri"/>
                         </a:rPr>
-                        <a:t>Reglas de negocio repetidas en la interfaz</a:t>
+                        <a:t>Dos peticiones a la vez podían escribir los mismos JSON</a:t>
                       </a:r>
                     </a:p>
                   </a:txBody>
@@ -9130,7 +9154,7 @@
                           </a:solidFill>
                           <a:latin typeface="Calibri"/>
                         </a:rPr>
-                        <a:t>Reglas solo en servicios; la interfaz muestra ValidacionException</a:t>
+                        <a:t>Middleware que atiende una petición a la vez, y escritura atómica</a:t>
                       </a:r>
                     </a:p>
                   </a:txBody>
@@ -9223,7 +9247,7 @@
           <a:noFill/>
         </p:spPr>
         <p:txBody>
-          <a:bodyPr wrap="square" anchor="t" lIns="45720" rIns="45720">
+          <a:bodyPr wrap="square" lIns="45720" rIns="45720">
             <a:spAutoFit/>
           </a:bodyPr>
           <a:lstStyle/>
@@ -9258,7 +9282,7 @@
           <a:noFill/>
         </p:spPr>
         <p:txBody>
-          <a:bodyPr wrap="square" anchor="t" lIns="45720" rIns="45720">
+          <a:bodyPr wrap="square" lIns="45720" rIns="45720">
             <a:spAutoFit/>
           </a:bodyPr>
           <a:lstStyle/>
@@ -9293,7 +9317,7 @@
           <a:noFill/>
         </p:spPr>
         <p:txBody>
-          <a:bodyPr wrap="square" anchor="t" lIns="45720" rIns="45720">
+          <a:bodyPr wrap="square" lIns="45720" rIns="45720">
             <a:spAutoFit/>
           </a:bodyPr>
           <a:lstStyle/>
@@ -9306,7 +9330,7 @@
                 </a:solidFill>
                 <a:latin typeface="Calibri"/>
               </a:rPr>
-              <a:t>Sistema de biblioteca · Programación II</a:t>
+              <a:t>Sistema de biblioteca · Programación II · Universidad San Pablo de Guatemala</a:t>
             </a:r>
           </a:p>
         </p:txBody>
@@ -9328,7 +9352,7 @@
           <a:noFill/>
         </p:spPr>
         <p:txBody>
-          <a:bodyPr wrap="square" anchor="t" lIns="45720" rIns="45720">
+          <a:bodyPr wrap="square" lIns="45720" rIns="45720">
             <a:spAutoFit/>
           </a:bodyPr>
           <a:lstStyle/>
@@ -9355,7 +9379,7 @@
         <p:spPr>
           <a:xfrm>
             <a:off x="548640" y="1645920"/>
-            <a:ext cx="6949440" cy="4389120"/>
+            <a:ext cx="7223760" cy="4389120"/>
           </a:xfrm>
           <a:prstGeom prst="roundRect">
             <a:avLst>
@@ -9400,7 +9424,7 @@
         <p:spPr>
           <a:xfrm>
             <a:off x="777240" y="1828800"/>
-            <a:ext cx="6583680" cy="4023360"/>
+            <a:ext cx="6858000" cy="4023360"/>
           </a:xfrm>
           <a:prstGeom prst="rect">
             <a:avLst/>
@@ -9408,7 +9432,7 @@
           <a:noFill/>
         </p:spPr>
         <p:txBody>
-          <a:bodyPr wrap="square" anchor="t" lIns="45720" rIns="45720">
+          <a:bodyPr wrap="square" lIns="45720" rIns="45720">
             <a:spAutoFit/>
           </a:bodyPr>
           <a:lstStyle/>
@@ -9489,7 +9513,7 @@
                 </a:solidFill>
                 <a:latin typeface="Consolas"/>
               </a:rPr>
-              <a:t>test: agrega pruebas unitarias de los modelos del dominio</a:t>
+              <a:t>chore: reemplaza la aplicación de escritorio por la plantilla ASP.NET Core MVC</a:t>
             </a:r>
           </a:p>
           <a:p>
@@ -9505,7 +9529,7 @@
                 </a:solidFill>
                 <a:latin typeface="Consolas"/>
               </a:rPr>
-              <a:t>feat: agrega el módulo de libros con búsqueda, filtros y formulario</a:t>
+              <a:t>feat: agrega los controladores de inicio, libros y usuarios</a:t>
             </a:r>
           </a:p>
           <a:p>
@@ -9521,7 +9545,7 @@
                 </a:solidFill>
                 <a:latin typeface="Consolas"/>
               </a:rPr>
-              <a:t>feat: integra la ventana principal, el menú de navegación y la pantalla de inicio</a:t>
+              <a:t>feat: agrega las vistas Razor de libros y usuarios con formularios y validación</a:t>
             </a:r>
           </a:p>
           <a:p>
@@ -9537,7 +9561,7 @@
                 </a:solidFill>
                 <a:latin typeface="Consolas"/>
               </a:rPr>
-              <a:t>docs: agrega los diagramas de clases, secuencia, actividad, estados y arquitectura</a:t>
+              <a:t>test: agrega pruebas de integración de la aplicación web MVC</a:t>
             </a:r>
           </a:p>
         </p:txBody>
@@ -9550,8 +9574,8 @@
         </p:nvSpPr>
         <p:spPr>
           <a:xfrm>
-            <a:off x="7772400" y="1645920"/>
-            <a:ext cx="3886200" cy="4389120"/>
+            <a:off x="7955279" y="1645920"/>
+            <a:ext cx="3703320" cy="4389120"/>
           </a:xfrm>
           <a:prstGeom prst="roundRect">
             <a:avLst>
@@ -9597,8 +9621,8 @@
         </p:nvSpPr>
         <p:spPr>
           <a:xfrm>
-            <a:off x="7909560" y="1737360"/>
-            <a:ext cx="3611880" cy="411480"/>
+            <a:off x="8092440" y="1737360"/>
+            <a:ext cx="3429000" cy="411480"/>
           </a:xfrm>
           <a:prstGeom prst="rect">
             <a:avLst/>
@@ -9606,7 +9630,7 @@
           <a:noFill/>
         </p:spPr>
         <p:txBody>
-          <a:bodyPr wrap="square" anchor="t" lIns="45720" rIns="45720">
+          <a:bodyPr wrap="square" lIns="45720" rIns="45720">
             <a:spAutoFit/>
           </a:bodyPr>
           <a:lstStyle/>
@@ -9632,8 +9656,8 @@
         </p:nvSpPr>
         <p:spPr>
           <a:xfrm>
-            <a:off x="7909560" y="2194560"/>
-            <a:ext cx="3611880" cy="3749039"/>
+            <a:off x="8092440" y="2194560"/>
+            <a:ext cx="3429000" cy="3749039"/>
           </a:xfrm>
           <a:prstGeom prst="rect">
             <a:avLst/>
@@ -9789,7 +9813,7 @@
           <a:noFill/>
         </p:spPr>
         <p:txBody>
-          <a:bodyPr wrap="square" anchor="t" lIns="45720" rIns="45720">
+          <a:bodyPr wrap="square" lIns="45720" rIns="45720">
             <a:spAutoFit/>
           </a:bodyPr>
           <a:lstStyle/>
@@ -9824,7 +9848,7 @@
           <a:noFill/>
         </p:spPr>
         <p:txBody>
-          <a:bodyPr wrap="square" anchor="t" lIns="45720" rIns="45720">
+          <a:bodyPr wrap="square" lIns="45720" rIns="45720">
             <a:spAutoFit/>
           </a:bodyPr>
           <a:lstStyle/>
@@ -9837,7 +9861,7 @@
                 </a:solidFill>
                 <a:latin typeface="Calibri"/>
               </a:rPr>
-              <a:t>Sistema de biblioteca · Programación II</a:t>
+              <a:t>Sistema de biblioteca · Programación II · Universidad San Pablo de Guatemala</a:t>
             </a:r>
           </a:p>
         </p:txBody>
@@ -9859,7 +9883,7 @@
           <a:noFill/>
         </p:spPr>
         <p:txBody>
-          <a:bodyPr wrap="square" anchor="t" lIns="45720" rIns="45720">
+          <a:bodyPr wrap="square" lIns="45720" rIns="45720">
             <a:spAutoFit/>
           </a:bodyPr>
           <a:lstStyle/>
@@ -9941,7 +9965,7 @@
           <a:noFill/>
         </p:spPr>
         <p:txBody>
-          <a:bodyPr wrap="square" anchor="t" lIns="45720" rIns="45720">
+          <a:bodyPr wrap="square" lIns="45720" rIns="45720">
             <a:spAutoFit/>
           </a:bodyPr>
           <a:lstStyle/>
@@ -10009,7 +10033,7 @@
                 </a:solidFill>
                 <a:latin typeface="Calibri"/>
               </a:rPr>
-              <a:t>• Las reglas de negocio viven en la lógica y están probadas</a:t>
+              <a:t>• La aplicación sigue el patrón MVC de ASP.NET Core</a:t>
             </a:r>
           </a:p>
           <a:p>
@@ -10025,7 +10049,7 @@
                 </a:solidFill>
                 <a:latin typeface="Calibri"/>
               </a:rPr>
-              <a:t>• Los datos persisten en JSON y se recuperan al reiniciar</a:t>
+              <a:t>• Las reglas de negocio viven en la lógica y están probadas</a:t>
             </a:r>
           </a:p>
           <a:p>
@@ -10041,7 +10065,7 @@
                 </a:solidFill>
                 <a:latin typeface="Calibri"/>
               </a:rPr>
-              <a:t>• Historial en GitHub ordenado por capas</a:t>
+              <a:t>• Los datos persisten en JSON y se recuperan al reiniciar</a:t>
             </a:r>
           </a:p>
         </p:txBody>
@@ -10110,7 +10134,7 @@
           <a:noFill/>
         </p:spPr>
         <p:txBody>
-          <a:bodyPr wrap="square" anchor="t" lIns="45720" rIns="45720">
+          <a:bodyPr wrap="square" lIns="45720" rIns="45720">
             <a:spAutoFit/>
           </a:bodyPr>
           <a:lstStyle/>
@@ -10162,7 +10186,7 @@
                 </a:solidFill>
                 <a:latin typeface="Calibri"/>
               </a:rPr>
-              <a:t>• 1. Abrir la app y recorrer el menú</a:t>
+              <a:t>• 1. dotnet run y abrir el navegador</a:t>
             </a:r>
           </a:p>
           <a:p>
@@ -10178,7 +10202,7 @@
                 </a:solidFill>
                 <a:latin typeface="Calibri"/>
               </a:rPr>
-              <a:t>• 2. Registrar un libro (primero con un error)</a:t>
+              <a:t>• 2. Recorrer el menú; registrar un libro (primero con error)</a:t>
             </a:r>
           </a:p>
           <a:p>
@@ -10258,7 +10282,7 @@
                 </a:solidFill>
                 <a:latin typeface="Calibri"/>
               </a:rPr>
-              <a:t>• 7. Cerrar, abrir y comprobar que los datos siguen</a:t>
+              <a:t>• 7. Detener, volver a iniciar y comprobar los datos</a:t>
             </a:r>
           </a:p>
         </p:txBody>
@@ -10341,7 +10365,7 @@
           <a:noFill/>
         </p:spPr>
         <p:txBody>
-          <a:bodyPr wrap="square" anchor="t" lIns="45720" rIns="45720">
+          <a:bodyPr wrap="square" lIns="45720" rIns="45720">
             <a:spAutoFit/>
           </a:bodyPr>
           <a:lstStyle/>
@@ -10376,7 +10400,7 @@
           <a:noFill/>
         </p:spPr>
         <p:txBody>
-          <a:bodyPr wrap="square" anchor="t" lIns="45720" rIns="45720">
+          <a:bodyPr wrap="square" lIns="45720" rIns="45720">
             <a:spAutoFit/>
           </a:bodyPr>
           <a:lstStyle/>
@@ -10411,7 +10435,7 @@
           <a:noFill/>
         </p:spPr>
         <p:txBody>
-          <a:bodyPr wrap="square" anchor="t" lIns="45720" rIns="45720">
+          <a:bodyPr wrap="square" lIns="45720" rIns="45720">
             <a:spAutoFit/>
           </a:bodyPr>
           <a:lstStyle/>
@@ -10424,7 +10448,7 @@
                 </a:solidFill>
                 <a:latin typeface="Calibri"/>
               </a:rPr>
-              <a:t>Sistema de biblioteca · Programación II</a:t>
+              <a:t>Sistema de biblioteca · Programación II · Universidad San Pablo de Guatemala</a:t>
             </a:r>
           </a:p>
         </p:txBody>
@@ -10446,7 +10470,7 @@
           <a:noFill/>
         </p:spPr>
         <p:txBody>
-          <a:bodyPr wrap="square" anchor="t" lIns="45720" rIns="45720">
+          <a:bodyPr wrap="square" lIns="45720" rIns="45720">
             <a:spAutoFit/>
           </a:bodyPr>
           <a:lstStyle/>
@@ -10528,7 +10552,7 @@
           <a:noFill/>
         </p:spPr>
         <p:txBody>
-          <a:bodyPr wrap="square" anchor="t" lIns="45720" rIns="45720">
+          <a:bodyPr wrap="square" lIns="45720" rIns="45720">
             <a:spAutoFit/>
           </a:bodyPr>
           <a:lstStyle/>
@@ -10697,7 +10721,7 @@
           <a:noFill/>
         </p:spPr>
         <p:txBody>
-          <a:bodyPr wrap="square" anchor="t" lIns="45720" rIns="45720">
+          <a:bodyPr wrap="square" lIns="45720" rIns="45720">
             <a:spAutoFit/>
           </a:bodyPr>
           <a:lstStyle/>
@@ -10866,7 +10890,7 @@
           <a:noFill/>
         </p:spPr>
         <p:txBody>
-          <a:bodyPr wrap="square" anchor="t" lIns="45720" rIns="45720">
+          <a:bodyPr wrap="square" lIns="45720" rIns="45720">
             <a:spAutoFit/>
           </a:bodyPr>
           <a:lstStyle/>
@@ -10918,7 +10942,7 @@
                 </a:solidFill>
                 <a:latin typeface="Calibri"/>
               </a:rPr>
-              <a:t>• Aplicación de escritorio en C# (.NET 8)</a:t>
+              <a:t>• Aplicación web ASP.NET Core MVC (C#, .NET 8)</a:t>
             </a:r>
           </a:p>
           <a:p>
@@ -11049,7 +11073,7 @@
           <a:noFill/>
         </p:spPr>
         <p:txBody>
-          <a:bodyPr wrap="square" anchor="t" lIns="45720" rIns="45720">
+          <a:bodyPr wrap="square" lIns="45720" rIns="45720">
             <a:spAutoFit/>
           </a:bodyPr>
           <a:lstStyle/>
@@ -11084,7 +11108,7 @@
           <a:noFill/>
         </p:spPr>
         <p:txBody>
-          <a:bodyPr wrap="square" anchor="t" lIns="45720" rIns="45720">
+          <a:bodyPr wrap="square" lIns="45720" rIns="45720">
             <a:spAutoFit/>
           </a:bodyPr>
           <a:lstStyle/>
@@ -11119,7 +11143,7 @@
           <a:noFill/>
         </p:spPr>
         <p:txBody>
-          <a:bodyPr wrap="square" anchor="t" lIns="45720" rIns="45720">
+          <a:bodyPr wrap="square" lIns="45720" rIns="45720">
             <a:spAutoFit/>
           </a:bodyPr>
           <a:lstStyle/>
@@ -11132,7 +11156,7 @@
                 </a:solidFill>
                 <a:latin typeface="Calibri"/>
               </a:rPr>
-              <a:t>Sistema de biblioteca · Programación II</a:t>
+              <a:t>Sistema de biblioteca · Programación II · Universidad San Pablo de Guatemala</a:t>
             </a:r>
           </a:p>
         </p:txBody>
@@ -11154,7 +11178,7 @@
           <a:noFill/>
         </p:spPr>
         <p:txBody>
-          <a:bodyPr wrap="square" anchor="t" lIns="45720" rIns="45720">
+          <a:bodyPr wrap="square" lIns="45720" rIns="45720">
             <a:spAutoFit/>
           </a:bodyPr>
           <a:lstStyle/>
@@ -11236,7 +11260,7 @@
           <a:noFill/>
         </p:spPr>
         <p:txBody>
-          <a:bodyPr wrap="square" anchor="t" lIns="45720" rIns="45720">
+          <a:bodyPr wrap="square" lIns="45720" rIns="45720">
             <a:spAutoFit/>
           </a:bodyPr>
           <a:lstStyle/>
@@ -11288,7 +11312,7 @@
                 </a:solidFill>
                 <a:latin typeface="Calibri"/>
               </a:rPr>
-              <a:t>• Gestionar catálogo, usuarios, préstamos, devoluciones y multas aplicando POO y UML, con datos en archivos JSON</a:t>
+              <a:t>• Gestionar catálogo, usuarios, préstamos, devoluciones y multas con una aplicación web, aplicando POO y UML, y guardando los datos en archivos JSON</a:t>
             </a:r>
           </a:p>
         </p:txBody>
@@ -11301,8 +11325,8 @@
         </p:nvSpPr>
         <p:spPr>
           <a:xfrm>
-            <a:off x="685800" y="3063240"/>
-            <a:ext cx="5212080" cy="3017520"/>
+            <a:off x="685800" y="3246120"/>
+            <a:ext cx="5212080" cy="2834640"/>
           </a:xfrm>
           <a:prstGeom prst="rect">
             <a:avLst/>
@@ -11336,7 +11360,7 @@
                 </a:solidFill>
                 <a:latin typeface="Calibri"/>
               </a:rPr>
-              <a:t> analizar y documentar, modelar en UML, implementar POO, persistir en JSON, construir la interfaz, probar y versionar en GitHub</a:t>
+              <a:t> analizar y documentar, modelar en UML, implementar POO, persistir en JSON, construir la interfaz web, probar y versionar en GitHub</a:t>
             </a:r>
           </a:p>
         </p:txBody>
@@ -11405,7 +11429,7 @@
           <a:noFill/>
         </p:spPr>
         <p:txBody>
-          <a:bodyPr wrap="square" anchor="t" lIns="45720" rIns="45720">
+          <a:bodyPr wrap="square" lIns="45720" rIns="45720">
             <a:spAutoFit/>
           </a:bodyPr>
           <a:lstStyle/>
@@ -11542,7 +11566,7 @@
           <a:noFill/>
         </p:spPr>
         <p:txBody>
-          <a:bodyPr wrap="square" anchor="t" lIns="45720" rIns="45720">
+          <a:bodyPr wrap="square" lIns="45720" rIns="45720">
             <a:spAutoFit/>
           </a:bodyPr>
           <a:lstStyle/>
@@ -11594,7 +11618,7 @@
                 </a:solidFill>
                 <a:latin typeface="Calibri"/>
               </a:rPr>
-              <a:t>• Un solo puesto de trabajo, sin inicio de sesión</a:t>
+              <a:t>• Sin inicio de sesión; una instancia y una petición a la vez</a:t>
             </a:r>
           </a:p>
           <a:p>
@@ -11693,7 +11717,7 @@
           <a:noFill/>
         </p:spPr>
         <p:txBody>
-          <a:bodyPr wrap="square" anchor="t" lIns="45720" rIns="45720">
+          <a:bodyPr wrap="square" lIns="45720" rIns="45720">
             <a:spAutoFit/>
           </a:bodyPr>
           <a:lstStyle/>
@@ -11728,7 +11752,7 @@
           <a:noFill/>
         </p:spPr>
         <p:txBody>
-          <a:bodyPr wrap="square" anchor="t" lIns="45720" rIns="45720">
+          <a:bodyPr wrap="square" lIns="45720" rIns="45720">
             <a:spAutoFit/>
           </a:bodyPr>
           <a:lstStyle/>
@@ -11763,7 +11787,7 @@
           <a:noFill/>
         </p:spPr>
         <p:txBody>
-          <a:bodyPr wrap="square" anchor="t" lIns="45720" rIns="45720">
+          <a:bodyPr wrap="square" lIns="45720" rIns="45720">
             <a:spAutoFit/>
           </a:bodyPr>
           <a:lstStyle/>
@@ -11776,7 +11800,7 @@
                 </a:solidFill>
                 <a:latin typeface="Calibri"/>
               </a:rPr>
-              <a:t>Sistema de biblioteca · Programación II</a:t>
+              <a:t>Sistema de biblioteca · Programación II · Universidad San Pablo de Guatemala</a:t>
             </a:r>
           </a:p>
         </p:txBody>
@@ -11798,7 +11822,7 @@
           <a:noFill/>
         </p:spPr>
         <p:txBody>
-          <a:bodyPr wrap="square" anchor="t" lIns="45720" rIns="45720">
+          <a:bodyPr wrap="square" lIns="45720" rIns="45720">
             <a:spAutoFit/>
           </a:bodyPr>
           <a:lstStyle/>
@@ -12451,7 +12475,7 @@
           <a:noFill/>
         </p:spPr>
         <p:txBody>
-          <a:bodyPr wrap="square" anchor="t" lIns="45720" rIns="45720">
+          <a:bodyPr wrap="square" lIns="45720" rIns="45720">
             <a:spAutoFit/>
           </a:bodyPr>
           <a:lstStyle/>
@@ -12503,7 +12527,7 @@
                 </a:solidFill>
                 <a:latin typeface="Calibri"/>
               </a:rPr>
-              <a:t>• C# / .NET 8, POO y UML</a:t>
+              <a:t>• C# / .NET 8, ASP.NET Core MVC</a:t>
             </a:r>
           </a:p>
           <a:p>
@@ -12519,7 +12543,7 @@
                 </a:solidFill>
                 <a:latin typeface="Calibri"/>
               </a:rPr>
-              <a:t>• Datos JSON en UTF-8</a:t>
+              <a:t>• POO y UML</a:t>
             </a:r>
           </a:p>
           <a:p>
@@ -12535,7 +12559,7 @@
                 </a:solidFill>
                 <a:latin typeface="Calibri"/>
               </a:rPr>
-              <a:t>• Portable y probable</a:t>
+              <a:t>• Datos JSON en UTF-8</a:t>
             </a:r>
           </a:p>
         </p:txBody>
@@ -12604,7 +12628,7 @@
           <a:noFill/>
         </p:spPr>
         <p:txBody>
-          <a:bodyPr wrap="square" anchor="t" lIns="45720" rIns="45720">
+          <a:bodyPr wrap="square" lIns="45720" rIns="45720">
             <a:spAutoFit/>
           </a:bodyPr>
           <a:lstStyle/>
@@ -12755,7 +12779,7 @@
           <a:noFill/>
         </p:spPr>
         <p:txBody>
-          <a:bodyPr wrap="square" anchor="t" lIns="45720" rIns="45720">
+          <a:bodyPr wrap="square" lIns="45720" rIns="45720">
             <a:spAutoFit/>
           </a:bodyPr>
           <a:lstStyle/>
@@ -12790,7 +12814,7 @@
           <a:noFill/>
         </p:spPr>
         <p:txBody>
-          <a:bodyPr wrap="square" anchor="t" lIns="45720" rIns="45720">
+          <a:bodyPr wrap="square" lIns="45720" rIns="45720">
             <a:spAutoFit/>
           </a:bodyPr>
           <a:lstStyle/>
@@ -12825,7 +12849,7 @@
           <a:noFill/>
         </p:spPr>
         <p:txBody>
-          <a:bodyPr wrap="square" anchor="t" lIns="45720" rIns="45720">
+          <a:bodyPr wrap="square" lIns="45720" rIns="45720">
             <a:spAutoFit/>
           </a:bodyPr>
           <a:lstStyle/>
@@ -12838,7 +12862,7 @@
                 </a:solidFill>
                 <a:latin typeface="Calibri"/>
               </a:rPr>
-              <a:t>Sistema de biblioteca · Programación II</a:t>
+              <a:t>Sistema de biblioteca · Programación II · Universidad San Pablo de Guatemala</a:t>
             </a:r>
           </a:p>
         </p:txBody>
@@ -12860,7 +12884,7 @@
           <a:noFill/>
         </p:spPr>
         <p:txBody>
-          <a:bodyPr wrap="square" anchor="t" lIns="45720" rIns="45720">
+          <a:bodyPr wrap="square" lIns="45720" rIns="45720">
             <a:spAutoFit/>
           </a:bodyPr>
           <a:lstStyle/>
@@ -12966,7 +12990,7 @@
           <a:noFill/>
         </p:spPr>
         <p:txBody>
-          <a:bodyPr wrap="square" anchor="t" lIns="45720" rIns="45720">
+          <a:bodyPr wrap="square" lIns="45720" rIns="45720">
             <a:spAutoFit/>
           </a:bodyPr>
           <a:lstStyle/>
@@ -13027,7 +13051,7 @@
                 </a:solidFill>
                 <a:latin typeface="Calibri"/>
               </a:rPr>
-              <a:t> opera el sistema</a:t>
+              <a:t> opera el sistema desde el navegador</a:t>
             </a:r>
           </a:p>
           <a:p>
@@ -13160,7 +13184,7 @@
           <a:noFill/>
         </p:spPr>
         <p:txBody>
-          <a:bodyPr wrap="square" anchor="t" lIns="45720" rIns="45720">
+          <a:bodyPr wrap="square" lIns="45720" rIns="45720">
             <a:spAutoFit/>
           </a:bodyPr>
           <a:lstStyle/>
@@ -13195,7 +13219,7 @@
           <a:noFill/>
         </p:spPr>
         <p:txBody>
-          <a:bodyPr wrap="square" anchor="t" lIns="45720" rIns="45720">
+          <a:bodyPr wrap="square" lIns="45720" rIns="45720">
             <a:spAutoFit/>
           </a:bodyPr>
           <a:lstStyle/>
@@ -13208,7 +13232,7 @@
                 </a:solidFill>
                 <a:latin typeface="Calibri"/>
               </a:rPr>
-              <a:t>El código replica este modelo</a:t>
+              <a:t>El modelo (Biblioteca.Core) replica este diagrama</a:t>
             </a:r>
           </a:p>
         </p:txBody>
@@ -13230,7 +13254,7 @@
           <a:noFill/>
         </p:spPr>
         <p:txBody>
-          <a:bodyPr wrap="square" anchor="t" lIns="45720" rIns="45720">
+          <a:bodyPr wrap="square" lIns="45720" rIns="45720">
             <a:spAutoFit/>
           </a:bodyPr>
           <a:lstStyle/>
@@ -13243,7 +13267,7 @@
                 </a:solidFill>
                 <a:latin typeface="Calibri"/>
               </a:rPr>
-              <a:t>Sistema de biblioteca · Programación II</a:t>
+              <a:t>Sistema de biblioteca · Programación II · Universidad San Pablo de Guatemala</a:t>
             </a:r>
           </a:p>
         </p:txBody>
@@ -13265,7 +13289,7 @@
           <a:noFill/>
         </p:spPr>
         <p:txBody>
-          <a:bodyPr wrap="square" anchor="t" lIns="45720" rIns="45720">
+          <a:bodyPr wrap="square" lIns="45720" rIns="45720">
             <a:spAutoFit/>
           </a:bodyPr>
           <a:lstStyle/>
@@ -13371,7 +13395,7 @@
           <a:noFill/>
         </p:spPr>
         <p:txBody>
-          <a:bodyPr wrap="square" anchor="t" lIns="45720" rIns="45720">
+          <a:bodyPr wrap="square" lIns="45720" rIns="45720">
             <a:spAutoFit/>
           </a:bodyPr>
           <a:lstStyle/>
@@ -13554,7 +13578,7 @@
           <a:noFill/>
         </p:spPr>
         <p:txBody>
-          <a:bodyPr wrap="square" anchor="t" lIns="45720" rIns="45720">
+          <a:bodyPr wrap="square" lIns="45720" rIns="45720">
             <a:spAutoFit/>
           </a:bodyPr>
           <a:lstStyle/>
@@ -13589,7 +13613,7 @@
           <a:noFill/>
         </p:spPr>
         <p:txBody>
-          <a:bodyPr wrap="square" anchor="t" lIns="45720" rIns="45720">
+          <a:bodyPr wrap="square" lIns="45720" rIns="45720">
             <a:spAutoFit/>
           </a:bodyPr>
           <a:lstStyle/>
@@ -13602,7 +13626,7 @@
                 </a:solidFill>
                 <a:latin typeface="Calibri"/>
               </a:rPr>
-              <a:t>Desde el formulario hasta los archivos JSON</a:t>
+              <a:t>Del formulario al controlador, los servicios y los archivos JSON</a:t>
             </a:r>
           </a:p>
         </p:txBody>
@@ -13624,7 +13648,7 @@
           <a:noFill/>
         </p:spPr>
         <p:txBody>
-          <a:bodyPr wrap="square" anchor="t" lIns="45720" rIns="45720">
+          <a:bodyPr wrap="square" lIns="45720" rIns="45720">
             <a:spAutoFit/>
           </a:bodyPr>
           <a:lstStyle/>
@@ -13637,7 +13661,7 @@
                 </a:solidFill>
                 <a:latin typeface="Calibri"/>
               </a:rPr>
-              <a:t>Sistema de biblioteca · Programación II</a:t>
+              <a:t>Sistema de biblioteca · Programación II · Universidad San Pablo de Guatemala</a:t>
             </a:r>
           </a:p>
         </p:txBody>
@@ -13659,7 +13683,7 @@
           <a:noFill/>
         </p:spPr>
         <p:txBody>
-          <a:bodyPr wrap="square" anchor="t" lIns="45720" rIns="45720">
+          <a:bodyPr wrap="square" lIns="45720" rIns="45720">
             <a:spAutoFit/>
           </a:bodyPr>
           <a:lstStyle/>
@@ -13693,8 +13717,8 @@
         </p:blipFill>
         <p:spPr>
           <a:xfrm>
-            <a:off x="1182206" y="1463040"/>
-            <a:ext cx="9797106" cy="4846320"/>
+            <a:off x="548640" y="1495618"/>
+            <a:ext cx="11064240" cy="4781163"/>
           </a:xfrm>
           <a:prstGeom prst="rect">
             <a:avLst/>
@@ -13779,7 +13803,7 @@
           <a:noFill/>
         </p:spPr>
         <p:txBody>
-          <a:bodyPr wrap="square" anchor="t" lIns="45720" rIns="45720">
+          <a:bodyPr wrap="square" lIns="45720" rIns="45720">
             <a:spAutoFit/>
           </a:bodyPr>
           <a:lstStyle/>
@@ -13814,7 +13838,7 @@
           <a:noFill/>
         </p:spPr>
         <p:txBody>
-          <a:bodyPr wrap="square" anchor="t" lIns="45720" rIns="45720">
+          <a:bodyPr wrap="square" lIns="45720" rIns="45720">
             <a:spAutoFit/>
           </a:bodyPr>
           <a:lstStyle/>
@@ -13849,7 +13873,7 @@
           <a:noFill/>
         </p:spPr>
         <p:txBody>
-          <a:bodyPr wrap="square" anchor="t" lIns="45720" rIns="45720">
+          <a:bodyPr wrap="square" lIns="45720" rIns="45720">
             <a:spAutoFit/>
           </a:bodyPr>
           <a:lstStyle/>
@@ -13862,7 +13886,7 @@
                 </a:solidFill>
                 <a:latin typeface="Calibri"/>
               </a:rPr>
-              <a:t>Sistema de biblioteca · Programación II</a:t>
+              <a:t>Sistema de biblioteca · Programación II · Universidad San Pablo de Guatemala</a:t>
             </a:r>
           </a:p>
         </p:txBody>
@@ -13884,7 +13908,7 @@
           <a:noFill/>
         </p:spPr>
         <p:txBody>
-          <a:bodyPr wrap="square" anchor="t" lIns="45720" rIns="45720">
+          <a:bodyPr wrap="square" lIns="45720" rIns="45720">
             <a:spAutoFit/>
           </a:bodyPr>
           <a:lstStyle/>
@@ -13991,7 +14015,7 @@
           <a:noFill/>
         </p:spPr>
         <p:txBody>
-          <a:bodyPr wrap="square" anchor="t" lIns="45720" rIns="45720">
+          <a:bodyPr wrap="square" lIns="45720" rIns="45720">
             <a:spAutoFit/>
           </a:bodyPr>
           <a:lstStyle/>
@@ -14142,7 +14166,7 @@
           <a:noFill/>
         </p:spPr>
         <p:txBody>
-          <a:bodyPr wrap="square" anchor="t" lIns="45720" rIns="45720">
+          <a:bodyPr wrap="square" lIns="45720" rIns="45720">
             <a:spAutoFit/>
           </a:bodyPr>
           <a:lstStyle/>
@@ -14155,7 +14179,7 @@
                 </a:solidFill>
                 <a:latin typeface="Calibri"/>
               </a:rPr>
-              <a:t>Arquitectura de la solución</a:t>
+              <a:t>Arquitectura de la solución: MVC</a:t>
             </a:r>
           </a:p>
         </p:txBody>
@@ -14177,7 +14201,7 @@
           <a:noFill/>
         </p:spPr>
         <p:txBody>
-          <a:bodyPr wrap="square" anchor="t" lIns="45720" rIns="45720">
+          <a:bodyPr wrap="square" lIns="45720" rIns="45720">
             <a:spAutoFit/>
           </a:bodyPr>
           <a:lstStyle/>
@@ -14190,7 +14214,7 @@
                 </a:solidFill>
                 <a:latin typeface="Calibri"/>
               </a:rPr>
-              <a:t>Tres proyectos, dependencias en un solo sentido</a:t>
+              <a:t>Controladores y vistas en la web; dominio y JSON en Biblioteca.Core</a:t>
             </a:r>
           </a:p>
         </p:txBody>
@@ -14212,7 +14236,7 @@
           <a:noFill/>
         </p:spPr>
         <p:txBody>
-          <a:bodyPr wrap="square" anchor="t" lIns="45720" rIns="45720">
+          <a:bodyPr wrap="square" lIns="45720" rIns="45720">
             <a:spAutoFit/>
           </a:bodyPr>
           <a:lstStyle/>
@@ -14225,7 +14249,7 @@
                 </a:solidFill>
                 <a:latin typeface="Calibri"/>
               </a:rPr>
-              <a:t>Sistema de biblioteca · Programación II</a:t>
+              <a:t>Sistema de biblioteca · Programación II · Universidad San Pablo de Guatemala</a:t>
             </a:r>
           </a:p>
         </p:txBody>
@@ -14247,7 +14271,7 @@
           <a:noFill/>
         </p:spPr>
         <p:txBody>
-          <a:bodyPr wrap="square" anchor="t" lIns="45720" rIns="45720">
+          <a:bodyPr wrap="square" lIns="45720" rIns="45720">
             <a:spAutoFit/>
           </a:bodyPr>
           <a:lstStyle/>
@@ -14281,8 +14305,8 @@
         </p:blipFill>
         <p:spPr>
           <a:xfrm>
-            <a:off x="847041" y="1463040"/>
-            <a:ext cx="5438236" cy="4846320"/>
+            <a:off x="457199" y="1893338"/>
+            <a:ext cx="6766560" cy="3985722"/>
           </a:xfrm>
           <a:prstGeom prst="rect">
             <a:avLst/>
@@ -14297,8 +14321,8 @@
         </p:nvSpPr>
         <p:spPr>
           <a:xfrm>
-            <a:off x="6858000" y="1645920"/>
-            <a:ext cx="4800600" cy="4389120"/>
+            <a:off x="7406640" y="1645920"/>
+            <a:ext cx="4251960" cy="4389120"/>
           </a:xfrm>
           <a:prstGeom prst="roundRect">
             <a:avLst>
@@ -14344,8 +14368,8 @@
         </p:nvSpPr>
         <p:spPr>
           <a:xfrm>
-            <a:off x="6995160" y="1737360"/>
-            <a:ext cx="4526280" cy="411480"/>
+            <a:off x="7543800" y="1737360"/>
+            <a:ext cx="3977640" cy="411480"/>
           </a:xfrm>
           <a:prstGeom prst="rect">
             <a:avLst/>
@@ -14353,7 +14377,7 @@
           <a:noFill/>
         </p:spPr>
         <p:txBody>
-          <a:bodyPr wrap="square" anchor="t" lIns="45720" rIns="45720">
+          <a:bodyPr wrap="square" lIns="45720" rIns="45720">
             <a:spAutoFit/>
           </a:bodyPr>
           <a:lstStyle/>
@@ -14366,7 +14390,7 @@
                 </a:solidFill>
                 <a:latin typeface="Calibri"/>
               </a:rPr>
-              <a:t>Capas</a:t>
+              <a:t>Patrón MVC</a:t>
             </a:r>
           </a:p>
         </p:txBody>
@@ -14379,8 +14403,8 @@
         </p:nvSpPr>
         <p:spPr>
           <a:xfrm>
-            <a:off x="6995160" y="2194560"/>
-            <a:ext cx="4526280" cy="3749039"/>
+            <a:off x="7543800" y="2194560"/>
+            <a:ext cx="3977640" cy="3749039"/>
           </a:xfrm>
           <a:prstGeom prst="rect">
             <a:avLst/>
@@ -14405,7 +14429,7 @@
                 </a:solidFill>
                 <a:latin typeface="Calibri"/>
               </a:rPr>
-              <a:t>• Biblioteca.App:</a:t>
+              <a:t>• Modelo:</a:t>
             </a:r>
             <a:r>
               <a:rPr sz="1500">
@@ -14414,7 +14438,7 @@
                 </a:solidFill>
                 <a:latin typeface="Calibri"/>
               </a:rPr>
-              <a:t> interfaz Avalonia (XAML + C#), sin lógica de negocio</a:t>
+              <a:t> Biblioteca.Core (entidades, servicios, JSON)</a:t>
             </a:r>
           </a:p>
           <a:p>
@@ -14430,7 +14454,7 @@
                 </a:solidFill>
                 <a:latin typeface="Calibri"/>
               </a:rPr>
-              <a:t>• Biblioteca.Core:</a:t>
+              <a:t>• Vista:</a:t>
             </a:r>
             <a:r>
               <a:rPr sz="1500">
@@ -14439,7 +14463,7 @@
                 </a:solidFill>
                 <a:latin typeface="Calibri"/>
               </a:rPr>
-              <a:t> modelos, servicios, políticas y repositorio JSON</a:t>
+              <a:t> Razor + Bootstrap, con ViewModels</a:t>
             </a:r>
           </a:p>
           <a:p>
@@ -14455,7 +14479,7 @@
                 </a:solidFill>
                 <a:latin typeface="Calibri"/>
               </a:rPr>
-              <a:t>• Biblioteca.Tests:</a:t>
+              <a:t>• Controlador:</a:t>
             </a:r>
             <a:r>
               <a:rPr sz="1500">
@@ -14464,7 +14488,7 @@
                 </a:solidFill>
                 <a:latin typeface="Calibri"/>
               </a:rPr>
-              <a:t> 70 pruebas xUnit</a:t>
+              <a:t> un controlador por módulo</a:t>
             </a:r>
           </a:p>
           <a:p>
@@ -14480,7 +14504,7 @@
                 </a:solidFill>
                 <a:latin typeface="Calibri"/>
               </a:rPr>
-              <a:t>• datos/:</a:t>
+              <a:t>• Program.cs:</a:t>
             </a:r>
             <a:r>
               <a:rPr sz="1500">
@@ -14489,7 +14513,7 @@
                 </a:solidFill>
                 <a:latin typeface="Calibri"/>
               </a:rPr>
-              <a:t> libros, usuarios, préstamos y multas en JSON</a:t>
+              <a:t> registra SistemaBiblioteca y las rutas</a:t>
             </a:r>
           </a:p>
         </p:txBody>

</xml_diff>

<commit_message>
fix: corrige los carnés de Angela y Carlos en la portada, el README y la presentación
</commit_message>
<xml_diff>
--- a/docs/Presentacion.pptx
+++ b/docs/Presentacion.pptx
@@ -4913,7 +4913,7 @@
                 </a:solidFill>
                 <a:latin typeface="Calibri"/>
               </a:rPr>
-              <a:t>Angela María Cruz Cifuentes (2600094)</a:t>
+              <a:t>Angela María Cruz Cifuentes (2600447)</a:t>
             </a:r>
           </a:p>
           <a:p>
@@ -4925,7 +4925,7 @@
                 </a:solidFill>
                 <a:latin typeface="Calibri"/>
               </a:rPr>
-              <a:t>Carlos Fernando Villatoro López (2600447)</a:t>
+              <a:t>Carlos Fernando Villatoro López (2600094)</a:t>
             </a:r>
           </a:p>
           <a:p>

</xml_diff>

<commit_message>
docs: regenera el documento de análisis y la presentación con el nuevo diseño
</commit_message>
<xml_diff>
--- a/docs/Presentacion.pptx
+++ b/docs/Presentacion.pptx
@@ -10942,7 +10942,7 @@
                 </a:solidFill>
                 <a:latin typeface="Calibri"/>
               </a:rPr>
-              <a:t>• Aplicación web ASP.NET Core MVC (C#, .NET 8)</a:t>
+              <a:t>• Aplicación web ASP.NET Core MVC (C#, .NET 8) con Tailwind CSS</a:t>
             </a:r>
           </a:p>
           <a:p>
@@ -14305,8 +14305,8 @@
         </p:blipFill>
         <p:spPr>
           <a:xfrm>
-            <a:off x="457199" y="1893338"/>
-            <a:ext cx="6766560" cy="3985722"/>
+            <a:off x="457199" y="1909914"/>
+            <a:ext cx="6766560" cy="3952571"/>
           </a:xfrm>
           <a:prstGeom prst="rect">
             <a:avLst/>
@@ -14463,7 +14463,7 @@
                 </a:solidFill>
                 <a:latin typeface="Calibri"/>
               </a:rPr>
-              <a:t> Razor + Bootstrap, con ViewModels</a:t>
+              <a:t> Razor + Tailwind CSS, con ViewModels</a:t>
             </a:r>
           </a:p>
           <a:p>

</xml_diff>